<commit_message>
TP6 : nouvelle interface (cartes, panier, suivi du livreur) et restaurant Yoshi Sushi
Co-Authored-By: Claude Opus 5.5 <noreply@anthropic.com>
</commit_message>
<xml_diff>
--- a/tp6/rendu_tp6/TP6_FastBite_NOM1_NOM2_NOM3.pptx
+++ b/tp6/rendu_tp6/TP6_FastBite_NOM1_NOM2_NOM3.pptx
@@ -581,7 +581,7 @@
           <a:lstStyle/>
           <a:p>
             <a:r>
-              <a:t>Bilan (30 s). Les quatre questions sont traitées et vérifiées par un programme de test qui simule les clics. Ce que nous retenons : séparer l'interface du métier nous a permis de réutiliser le TP5 sans le modifier. Les tests ont même révélé un bug du TP5. Limites : un seul client et pas de page livreur. Sources : le cours et le sujet de M. Segado, la documentation Oracle. L'IA Claude a généré la maquette, le storyboard et le code ; nous devons savoir expliquer chaque partie.</a:t>
+              <a:t>Bilan (30 s). Les quatre questions sont traitées et vérifiées par un programme de test qui simule les clics. Ce que nous retenons : séparer l'interface du métier nous a permis de réutiliser le TP5 sans le modifier. Les tests ont même révélé un bug du TP5. Limites : un seul client et un seul livreur. Sources : le cours et le sujet de M. Segado, la documentation Oracle. L'IA Claude a généré la maquette, le storyboard et le code ; nous devons savoir expliquer chaque partie.</a:t>
             </a:r>
           </a:p>
         </p:txBody>
@@ -721,7 +721,7 @@
           <a:lstStyle/>
           <a:p>
             <a:r>
-              <a:t>Q1 (40 s). La maquette a été générée par IA à partir de notre thème. Elle montre trois fenêtres : l'accueil avec la liste des restaurants, le menu avec le panier, et la commande avec le paiement et la note. C'est le parcours du client de notre diagramme de cas d'utilisation du TP2. On a déjà noté quel composant Swing sera utilisé pour chaque zone, ce qui a guidé le code.</a:t>
+              <a:t>Q1 (40 s). La maquette a été générée par IA à partir de notre thème. Elle montre trois fenêtres : l'accueil avec une carte par restaurant et notre livreur, le menu avec le panier, et la commande avec le paiement, le suivi de la livraison et les notes. C'est le parcours du client de notre diagramme de cas d'utilisation du TP2. On a déjà noté quel composant Swing sera utilisé pour chaque zone, ce qui a guidé le code.</a:t>
             </a:r>
           </a:p>
         </p:txBody>
@@ -861,7 +861,7 @@
           <a:lstStyle/>
           <a:p>
             <a:r>
-              <a:t>Q3, code (50 s). Chaque page est une classe qui hérite de JFrame. Dans le constructeur on crée les composants, on les range avec des layouts : BorderLayout pour les grandes zones, GridLayout pour la colonne de boutons. Puis on abonne la fenêtre aux clics avec addActionListener. Le main crée les données et affiche l'accueil dans le fil de Swing avec invokeLater.</a:t>
+              <a:t>Q3, code (50 s). Chaque page est une classe qui hérite de JFrame. Dans le constructeur on crée les composants, on les range avec des layouts : BorderLayout pour les grandes zones, GridLayout pour la grille de cartes. Pour l'apparence, notre classe Style hérite de JButton et de JPanel et redéfinit paintComponent : c'est nous qui dessinons les boutons arrondis et les cartes. Puis on abonne la fenêtre aux clics avec addActionListener. Le main crée les données et affiche l'accueil dans le fil de Swing avec invokeLater.</a:t>
             </a:r>
           </a:p>
         </p:txBody>
@@ -931,7 +931,7 @@
           <a:lstStyle/>
           <a:p>
             <a:r>
-              <a:t>Q3, résultat (40 s). Les trois fenêtres obtenues suivent la maquette. Le tableau du menu est rempli à partir des vrais objets Plat du restaurant, ce n'est pas du texte en dur. Nous avons choisi l'apparence Nimbus pour avoir le même rendu sur tous les ordinateurs.</a:t>
+              <a:t>Q3, résultat (40 s). Les trois fenêtres obtenues suivent la maquette. Les cartes sont créées à partir des vrais objets Restaurant et Plat du restaurant, ce n'est pas du texte en dur. Nous avons ajouté Yoshi Sushi dans les données et sa carte est apparue toute seule. Couleurs et composants dessinés sont regroupés dans la classe Style.</a:t>
             </a:r>
           </a:p>
         </p:txBody>
@@ -1001,7 +1001,7 @@
           <a:lstStyle/>
           <a:p>
             <a:r>
-              <a:t>Q4, listeners (50 s). Quand on clique, Swing appelle actionPerformed. getSource nous dit quel bouton a été cliqué. Pour Ajouter au panier, on prend la ligne sélectionnée dans le tableau, on appelle ajouterPlat sur la commande, puis on rafraîchit la liste du panier et le total. À droite le test : deux clics, le total passe à 14,5 euros. Sur la page 3 nous avons utilisé l'autre écriture, une classe anonyme par bouton.</a:t>
+              <a:t>Q4, listeners (50 s). Quand on clique, Swing appelle actionPerformed. getSource nous dit quel bouton a été cliqué. Chaque carte a son bouton Ajouter : sa position dans la liste des boutons dit quel plat ajouter, on appelle ajouterPlat sur la commande, puis on rafraîchit la liste du panier et le total. À droite le test : deux clics, le total passe à 14,5 euros. Sur la page 3 nous avons utilisé l'autre écriture, une classe anonyme par bouton.</a:t>
             </a:r>
           </a:p>
         </p:txBody>
@@ -1071,7 +1071,7 @@
           <a:lstStyle/>
           <a:p>
             <a:r>
-              <a:t>Q4, exceptions (50 s). Les méthodes du TP5 lèvent toujours leurs exceptions. Dans l'interface, c'est le listener qui fait le try/catch et qui affiche le message de l'exception dans une boîte de dialogue. Trois tests à droite : valider un panier vide, donner une note de 7, payer deux fois. Un nouveau cas apparaît avec l'interface : l'utilisateur peut taper du texte dans un champ numérique, on attrape NumberFormatException.</a:t>
+              <a:t>Q4, exceptions (50 s). Les méthodes du TP5 lèvent toujours leurs exceptions. Dans l'interface, c'est le listener qui fait le try/catch et qui affiche le message de l'exception dans une boîte de dialogue. Quatre tests à droite : valider un panier vide, donner une note de 7, confier une commande au livreur déjà en course, payer deux fois. Un nouveau cas apparaît avec l'interface : l'utilisateur peut taper du texte dans un champ numérique, on attrape NumberFormatException.</a:t>
             </a:r>
           </a:p>
         </p:txBody>
@@ -1141,7 +1141,7 @@
           <a:lstStyle/>
           <a:p>
             <a:r>
-              <a:t>Q4, fichiers (50 s). Les boutons appellent directement les méthodes du TP5 : sauvegarderMenu et chargerMenu pour le fichier texte, sauvegarderRestaurants et chargerRestaurants pour la sérialisation. Test de la sérialisation : on sauvegarde, on vide la liste, on recharge, les deux restaurants reviennent avec leurs menus et la note. Deux cas d'erreur : un fichier texte avec un prix non numérique, et un fichier .ser corrompu. Ce dernier test nous a fait trouver un bug du TP5 : le fichier restait ouvert après l'erreur, nous l'avons corrigé.</a:t>
+              <a:t>Q4, fichiers (50 s). Les boutons appellent directement les méthodes du TP5 : sauvegarderMenu et chargerMenu pour le fichier texte, sauvegarderRestaurants et chargerRestaurants pour la sérialisation. Test de la sérialisation : on sauvegarde, on vide la liste, on recharge, les trois restaurants reviennent avec leurs menus et la note. Deux cas d'erreur : un fichier texte avec un prix non numérique, et un fichier .ser corrompu. Ce dernier test nous a fait trouver un bug du TP5 : le fichier restait ouvert après l'erreur, nous l'avons corrigé.</a:t>
             </a:r>
           </a:p>
         </p:txBody>
@@ -4758,7 +4758,7 @@
                 </a:solidFill>
                 <a:latin typeface="Calibri"/>
               </a:rPr>
-              <a:t>• Fait : maquette, storyboard, 3 fenêtres Swing reliées, 13 boutons avec listener, exceptions affichées, fichier .txt et .ser depuis l'interface.</a:t>
+              <a:t>• Fait : maquette, storyboard, 3 fenêtres Swing reliées, un bouton avec listener sur chaque carte, exceptions affichées, fichiers .txt et .ser, suivi de la livraison par notre livreur.</a:t>
             </a:r>
           </a:p>
           <a:p>
@@ -4774,7 +4774,7 @@
                 </a:solidFill>
                 <a:latin typeface="Calibri"/>
               </a:rPr>
-              <a:t>• Vérifié : TestsTP6 simule les clics (doClick) : 27 vérifications passent ; les tests du TP5 passent toujours.</a:t>
+              <a:t>• Vérifié : TestsTP6 simule les clics (doClick) : 39 vérifications passent ; les tests du TP5 passent toujours.</a:t>
             </a:r>
           </a:p>
           <a:p>
@@ -4822,7 +4822,7 @@
                 </a:solidFill>
                 <a:latin typeface="Calibri"/>
               </a:rPr>
-              <a:t>• Limites : un seul client, pas d'écran de connexion ni de livreur ; les images de fenêtres sont des rendus du programme de test.</a:t>
+              <a:t>• Limites : un seul client et un seul livreur, pas d'écran de connexion ni de photos des plats ; les images de fenêtres sont des rendus du programme de test.</a:t>
             </a:r>
           </a:p>
           <a:p>
@@ -4838,7 +4838,7 @@
                 </a:solidFill>
                 <a:latin typeface="Calibri"/>
               </a:rPr>
-              <a:t>• Améliorations : séparer en Modèle-Vue-Contrôleur (TP7), ajouter la page de suivi de livraison.</a:t>
+              <a:t>• Améliorations : séparer en Modèle-Vue-Contrôleur (TP7), plusieurs livreurs, retirer un plat du panier.</a:t>
             </a:r>
           </a:p>
         </p:txBody>
@@ -5033,7 +5033,7 @@
                 </a:solidFill>
                 <a:latin typeface="Calibri"/>
               </a:rPr>
-              <a:t>• « fais le tp6 dans la suite du tp5 fastbite » (avec le sujet du TP6 et notre code du TP5 fournis à l'IA)</a:t>
+              <a:t>• « fais le tp6 dans la suite du tp5 fastbite », puis « inspire toi uber eats [...] rajoute le restaurant yoshi sushi » (sujet du TP6 et code du TP5 fournis à l'IA)</a:t>
             </a:r>
           </a:p>
         </p:txBody>
@@ -6408,7 +6408,7 @@
                 </a:solidFill>
                 <a:latin typeface="Calibri"/>
               </a:rPr>
-              <a:t>• Chaque zone correspond à un composant Swing (JList, JTable, JTextField, JButton) ; les pastilles bleues sont les boutons qui auront un listener.</a:t>
+              <a:t>• Présentation inspirée des applications de livraison (cartes, panier à droite, suivi du livreur) ; chaque zone est un composant Swing (JPanel, JLabel, JTextField, JButton), les pastilles bleues sont les boutons qui auront un listener.</a:t>
             </a:r>
           </a:p>
         </p:txBody>
@@ -6793,7 +6793,7 @@
                 </a:solidFill>
                 <a:latin typeface="Calibri"/>
               </a:rPr>
-              <a:t>• Bleu : un clic change de page (Voir le menu, Valider, Retour).</a:t>
+              <a:t>• Bleu : un clic change de page (Voir le menu, Commander, Retour, Suivre ma commande).</a:t>
             </a:r>
           </a:p>
           <a:p>
@@ -6873,7 +6873,7 @@
                 </a:solidFill>
                 <a:latin typeface="Calibri"/>
               </a:rPr>
-              <a:t>• Les fenêtres partagent un objet Donnees (restaurants, client).</a:t>
+              <a:t>• Les fenêtres partagent un objet Donnees (restaurants, client, livreur, commande en cours de livraison).</a:t>
             </a:r>
           </a:p>
         </p:txBody>
@@ -7156,8 +7156,8 @@
         </p:blipFill>
         <p:spPr>
           <a:xfrm>
-            <a:off x="833238" y="1051560"/>
-            <a:ext cx="5557283" cy="5120640"/>
+            <a:off x="677687" y="1051560"/>
+            <a:ext cx="5868385" cy="5120640"/>
           </a:xfrm>
           <a:prstGeom prst="rect">
             <a:avLst/>
@@ -7342,7 +7342,7 @@
                 </a:solidFill>
                 <a:latin typeface="Calibri"/>
               </a:rPr>
-              <a:t>• BorderLayout : 5 zones (nord, centre, est, sud). GridLayout : cases égales pour la colonne de boutons.</a:t>
+              <a:t>• BorderLayout : 5 zones. GridLayout à 3 colonnes : une carte par restaurant, toutes de même taille.</a:t>
             </a:r>
           </a:p>
           <a:p>
@@ -7358,7 +7358,7 @@
                 </a:solidFill>
                 <a:latin typeface="Calibri"/>
               </a:rPr>
-              <a:t>• JScrollPane autour de la JList : barre de défilement si la liste est longue.</a:t>
+              <a:t>• JScrollPane autour de la grille : barre de défilement s'il y a beaucoup de restaurants.</a:t>
             </a:r>
           </a:p>
           <a:p>
@@ -7374,7 +7374,7 @@
                 </a:solidFill>
                 <a:latin typeface="Calibri"/>
               </a:rPr>
-              <a:t>• addActionListener(this) : la fenêtre écoute ses boutons.</a:t>
+              <a:t>• addActionListener(this) : la fenêtre écoute ses boutons. Notre classe Style redéfinit paintComponent (boutons arrondis, cartes).</a:t>
             </a:r>
           </a:p>
           <a:p>
@@ -7673,8 +7673,8 @@
         </p:blipFill>
         <p:spPr>
           <a:xfrm>
-            <a:off x="482075" y="1097280"/>
-            <a:ext cx="4339369" cy="2743200"/>
+            <a:off x="589140" y="1097280"/>
+            <a:ext cx="4125238" cy="2743200"/>
           </a:xfrm>
           <a:prstGeom prst="rect">
             <a:avLst/>
@@ -7720,7 +7720,7 @@
                 </a:solidFill>
                 <a:latin typeface="Calibri"/>
               </a:rPr>
-              <a:t>Capture 5 — page 1 : accueil (JList + boutons)</a:t>
+              <a:t>Capture 5 — page 1 : accueil (une carte par restaurant, notre livreur)</a:t>
             </a:r>
           </a:p>
         </p:txBody>
@@ -7741,8 +7741,8 @@
         </p:blipFill>
         <p:spPr>
           <a:xfrm>
-            <a:off x="1374401" y="4206240"/>
-            <a:ext cx="2554717" cy="1920240"/>
+            <a:off x="1207926" y="4206240"/>
+            <a:ext cx="2887666" cy="1920240"/>
           </a:xfrm>
           <a:prstGeom prst="rect">
             <a:avLst/>
@@ -7795,7 +7795,7 @@
       </p:sp>
       <p:pic>
         <p:nvPicPr>
-          <p:cNvPr id="12" name="Picture 11" descr="q3_fenetre_menu.png"/>
+          <p:cNvPr id="12" name="Picture 11" descr="q3_fenetre_menu_yoshi.png"/>
           <p:cNvPicPr>
             <a:picLocks noChangeAspect="1"/>
           </p:cNvPicPr>
@@ -7809,8 +7809,8 @@
         </p:blipFill>
         <p:spPr>
           <a:xfrm>
-            <a:off x="5212080" y="1097280"/>
-            <a:ext cx="6720840" cy="2904654"/>
+            <a:off x="6303618" y="1097280"/>
+            <a:ext cx="4537762" cy="3017520"/>
           </a:xfrm>
           <a:prstGeom prst="rect">
             <a:avLst/>
@@ -7830,7 +7830,7 @@
         </p:nvSpPr>
         <p:spPr>
           <a:xfrm>
-            <a:off x="5212080" y="4020222"/>
+            <a:off x="5212080" y="4133088"/>
             <a:ext cx="6720840" cy="274320"/>
           </a:xfrm>
           <a:prstGeom prst="rect">
@@ -7856,7 +7856,7 @@
                 </a:solidFill>
                 <a:latin typeface="Calibri"/>
               </a:rPr>
-              <a:t>Capture 6 — page 2 : menu (JTable) et panier (JList)</a:t>
+              <a:t>Capture 6 — page 2 : menu (une carte par plat) et panier</a:t>
             </a:r>
           </a:p>
         </p:txBody>
@@ -7869,7 +7869,7 @@
         </p:nvSpPr>
         <p:spPr>
           <a:xfrm>
-            <a:off x="5303520" y="4413414"/>
+            <a:off x="5303520" y="4526280"/>
             <a:ext cx="6583680" cy="1828800"/>
           </a:xfrm>
           <a:prstGeom prst="rect">
@@ -7911,7 +7911,7 @@
                 </a:solidFill>
                 <a:latin typeface="Calibri"/>
               </a:rPr>
-              <a:t>• JTable en lecture seule pour le menu : le tableau lit le vrai menu du restaurant (objets Plat du TP3).</a:t>
+              <a:t>• Les cartes sont construites à partir des vrais objets Restaurant et Plat (TP3) : Yoshi Sushi, ajouté dans les données, apparaît sans toucher aux fenêtres.</a:t>
             </a:r>
           </a:p>
           <a:p>
@@ -7927,7 +7927,7 @@
                 </a:solidFill>
                 <a:latin typeface="Calibri"/>
               </a:rPr>
-              <a:t>• Apparence Nimbus : identique sur Windows, Mac et Linux.</a:t>
+              <a:t>• Charte FastBite (orange, noir, vert) regroupée dans la classe Style ; présentation inspirée des applications de livraison.</a:t>
             </a:r>
           </a:p>
         </p:txBody>
@@ -8211,7 +8211,7 @@
         <p:spPr>
           <a:xfrm>
             <a:off x="274320" y="1051560"/>
-            <a:ext cx="6035040" cy="4267635"/>
+            <a:ext cx="6035040" cy="4138313"/>
           </a:xfrm>
           <a:prstGeom prst="rect">
             <a:avLst/>
@@ -8231,7 +8231,7 @@
         </p:nvSpPr>
         <p:spPr>
           <a:xfrm>
-            <a:off x="274320" y="5337483"/>
+            <a:off x="274320" y="5208161"/>
             <a:ext cx="6035040" cy="274320"/>
           </a:xfrm>
           <a:prstGeom prst="rect">
@@ -8278,8 +8278,8 @@
         </p:blipFill>
         <p:spPr>
           <a:xfrm>
-            <a:off x="6620780" y="1097280"/>
-            <a:ext cx="5183598" cy="2240280"/>
+            <a:off x="7528107" y="1097280"/>
+            <a:ext cx="3368944" cy="2240280"/>
           </a:xfrm>
           <a:prstGeom prst="rect">
             <a:avLst/>
@@ -8325,7 +8325,7 @@
                 </a:solidFill>
                 <a:latin typeface="Calibri"/>
               </a:rPr>
-              <a:t>Capture 9 — test : 2 clics « Ajouter au panier » → total 14.5 EUR</a:t>
+              <a:t>Capture 9 — test : 2 clics « Ajouter » → total 14,50 €</a:t>
             </a:r>
           </a:p>
         </p:txBody>
@@ -8432,7 +8432,7 @@
                 </a:solidFill>
                 <a:latin typeface="Calibri"/>
               </a:rPr>
-              <a:t>• Deux façons vues au cours 6 : la fenêtre implémente ActionListener (getSource dit quel bouton), ou une classe anonyme par bouton.</a:t>
+              <a:t>• Deux façons vues au cours 6 : la fenêtre implémente ActionListener (getSource dit quel bouton ; sa position dans la liste des boutons donne le plat), ou une classe anonyme par bouton.</a:t>
             </a:r>
           </a:p>
           <a:p>
@@ -8732,7 +8732,7 @@
         <p:spPr>
           <a:xfrm>
             <a:off x="274320" y="1051560"/>
-            <a:ext cx="6309360" cy="4345228"/>
+            <a:ext cx="6309360" cy="4081881"/>
           </a:xfrm>
           <a:prstGeom prst="rect">
             <a:avLst/>
@@ -8752,7 +8752,7 @@
         </p:nvSpPr>
         <p:spPr>
           <a:xfrm>
-            <a:off x="274320" y="5415076"/>
+            <a:off x="274320" y="5151729"/>
             <a:ext cx="6309360" cy="274320"/>
           </a:xfrm>
           <a:prstGeom prst="rect">
@@ -8799,8 +8799,8 @@
         </p:blipFill>
         <p:spPr>
           <a:xfrm>
-            <a:off x="7920168" y="1097280"/>
-            <a:ext cx="2859143" cy="1051560"/>
+            <a:off x="8247472" y="1097280"/>
+            <a:ext cx="2204535" cy="713232"/>
           </a:xfrm>
           <a:prstGeom prst="rect">
             <a:avLst/>
@@ -8820,7 +8820,7 @@
         </p:nvSpPr>
         <p:spPr>
           <a:xfrm>
-            <a:off x="6766560" y="2167127"/>
+            <a:off x="6766560" y="1828800"/>
             <a:ext cx="5166360" cy="274320"/>
           </a:xfrm>
           <a:prstGeom prst="rect">
@@ -8867,8 +8867,8 @@
         </p:blipFill>
         <p:spPr>
           <a:xfrm>
-            <a:off x="8019825" y="2514599"/>
-            <a:ext cx="2659828" cy="1051560"/>
+            <a:off x="8247472" y="2112263"/>
+            <a:ext cx="2204535" cy="713232"/>
           </a:xfrm>
           <a:prstGeom prst="rect">
             <a:avLst/>
@@ -8888,7 +8888,7 @@
         </p:nvSpPr>
         <p:spPr>
           <a:xfrm>
-            <a:off x="6766560" y="3584447"/>
+            <a:off x="6766560" y="2843784"/>
             <a:ext cx="5166360" cy="274320"/>
           </a:xfrm>
           <a:prstGeom prst="rect">
@@ -8935,8 +8935,8 @@
         </p:blipFill>
         <p:spPr>
           <a:xfrm>
-            <a:off x="7459681" y="3931919"/>
-            <a:ext cx="3780117" cy="1051560"/>
+            <a:off x="8339328" y="3127247"/>
+            <a:ext cx="2020824" cy="713232"/>
           </a:xfrm>
           <a:prstGeom prst="rect">
             <a:avLst/>
@@ -8956,7 +8956,7 @@
         </p:nvSpPr>
         <p:spPr>
           <a:xfrm>
-            <a:off x="6766560" y="5001767"/>
+            <a:off x="6766560" y="3858767"/>
             <a:ext cx="5166360" cy="274320"/>
           </a:xfrm>
           <a:prstGeom prst="rect">
@@ -8987,15 +8987,83 @@
           </a:p>
         </p:txBody>
       </p:sp>
-      <p:sp>
-        <p:nvSpPr>
-          <p:cNvPr id="16" name="TextBox 15"/>
+      <p:pic>
+        <p:nvPicPr>
+          <p:cNvPr id="16" name="Picture 15" descr="q4_exc_livreur.png"/>
+          <p:cNvPicPr>
+            <a:picLocks noChangeAspect="1"/>
+          </p:cNvPicPr>
+          <p:nvPr/>
+        </p:nvPicPr>
+        <p:blipFill>
+          <a:blip r:embed="rId6"/>
+          <a:stretch>
+            <a:fillRect/>
+          </a:stretch>
+        </p:blipFill>
+        <p:spPr>
+          <a:xfrm>
+            <a:off x="8247472" y="4142231"/>
+            <a:ext cx="2204535" cy="713232"/>
+          </a:xfrm>
+          <a:prstGeom prst="rect">
+            <a:avLst/>
+          </a:prstGeom>
+          <a:ln w="9525">
+            <a:solidFill>
+              <a:srgbClr val="C4CAD4"/>
+            </a:solidFill>
+          </a:ln>
+        </p:spPr>
+      </p:pic>
+      <p:sp>
+        <p:nvSpPr>
+          <p:cNvPr id="17" name="TextBox 16"/>
           <p:cNvSpPr txBox="1"/>
           <p:nvPr/>
         </p:nvSpPr>
         <p:spPr>
           <a:xfrm>
-            <a:off x="6766560" y="5349239"/>
+            <a:off x="6766560" y="4873751"/>
+            <a:ext cx="5166360" cy="274320"/>
+          </a:xfrm>
+          <a:prstGeom prst="rect">
+            <a:avLst/>
+          </a:prstGeom>
+          <a:noFill/>
+        </p:spPr>
+        <p:txBody>
+          <a:bodyPr wrap="square" anchor="t" lIns="45720" rIns="45720" tIns="27432" bIns="27432">
+            <a:spAutoFit/>
+          </a:bodyPr>
+          <a:lstStyle/>
+          <a:p>
+            <a:pPr algn="ctr">
+              <a:spcAft>
+                <a:spcPts val="500"/>
+              </a:spcAft>
+            </a:pPr>
+            <a:r>
+              <a:rPr sz="1000" b="0" i="1">
+                <a:solidFill>
+                  <a:srgbClr val="555B66"/>
+                </a:solidFill>
+                <a:latin typeface="Calibri"/>
+              </a:rPr>
+              <a:t>Capture 14 bis — 2e commande pendant une livraison : LivreurIndisponibleException</a:t>
+            </a:r>
+          </a:p>
+        </p:txBody>
+      </p:sp>
+      <p:sp>
+        <p:nvSpPr>
+          <p:cNvPr id="18" name="TextBox 17"/>
+          <p:cNvSpPr txBox="1"/>
+          <p:nvPr/>
+        </p:nvSpPr>
+        <p:spPr>
+          <a:xfrm>
+            <a:off x="6766560" y="5157216"/>
             <a:ext cx="5166360" cy="1188720"/>
           </a:xfrm>
           <a:prstGeom prst="rect">
@@ -9472,8 +9540,8 @@
         </p:blipFill>
         <p:spPr>
           <a:xfrm>
-            <a:off x="6491779" y="1097280"/>
-            <a:ext cx="3109881" cy="1965960"/>
+            <a:off x="6568509" y="1097280"/>
+            <a:ext cx="2956420" cy="1965960"/>
           </a:xfrm>
           <a:prstGeom prst="rect">
             <a:avLst/>
@@ -9608,8 +9676,8 @@
         </p:blipFill>
         <p:spPr>
           <a:xfrm>
-            <a:off x="7954682" y="3447288"/>
-            <a:ext cx="2424355" cy="868680"/>
+            <a:off x="7936230" y="3447288"/>
+            <a:ext cx="2461260" cy="868680"/>
           </a:xfrm>
           <a:prstGeom prst="rect">
             <a:avLst/>
@@ -9676,8 +9744,8 @@
         </p:blipFill>
         <p:spPr>
           <a:xfrm>
-            <a:off x="7803328" y="4663440"/>
-            <a:ext cx="2727063" cy="822959"/>
+            <a:off x="7895012" y="4663440"/>
+            <a:ext cx="2543694" cy="822959"/>
           </a:xfrm>
           <a:prstGeom prst="rect">
             <a:avLst/>
@@ -9778,7 +9846,7 @@
                 </a:solidFill>
                 <a:latin typeface="Calibri"/>
               </a:rPr>
-              <a:t>• Test : liste vidée puis « Charger » → 2 restaurants, menus et note 4.5 retrouvés.</a:t>
+              <a:t>• Test : accueil vidé puis « Charger » → 3 restaurants, menus et note 4,5 retrouvés.</a:t>
             </a:r>
           </a:p>
         </p:txBody>

</xml_diff>